<commit_message>
Aplicar el logo y los colores de marca de Jurix Global a las presentaciones
Agrega el logo en portada, pie de página y cierre, cambia el acento
amarillo por el dorado de la marca y guarda el logo en versión para
fondo claro y oscuro.

Co-Authored-By: Claude Opus 5.5 <noreply@anthropic.com>
Claude-Session: https://claude.ai/code/session_01QAe3YyGWhdhctfhZWNy5HL
</commit_message>
<xml_diff>
--- a/jurix-global/presentacion-plan-ruta-segura-version-b.pptx
+++ b/jurix-global/presentacion-plan-ruta-segura-version-b.pptx
@@ -117,37 +117,37 @@
   <p:extLst>
     <p:ext uri="{521415D9-36F7-43E2-AB2F-B90AF26B5E84}">
       <p14:sectionLst xmlns:p14="http://schemas.microsoft.com/office/powerpoint/2010/main">
-        <p14:section name="Apertura" id="{2e3f658a-f1cc-707e-9b44-7f0159e1b605}">
+        <p14:section name="Apertura" id="{709f479f-c552-e7e9-62c6-4a6c8d7fe35a}">
           <p14:sldIdLst>
             <p14:sldId id="256"/>
           </p14:sldIdLst>
         </p14:section>
-        <p14:section name="El problema" id="{b3bf0e2a-d303-18a4-817b-26d7a07f808f}">
+        <p14:section name="El problema" id="{4704ffa8-205a-090a-b3c4-398687537b2b}">
           <p14:sldIdLst>
             <p14:sldId id="257"/>
             <p14:sldId id="258"/>
           </p14:sldIdLst>
         </p14:section>
-        <p14:section name="La solución" id="{4c0a79a3-66f3-32b8-7014-5135fc3758b6}">
+        <p14:section name="La solución" id="{35c0c289-ef6d-7bba-ad27-f678abefccd6}">
           <p14:sldIdLst>
             <p14:sldId id="259"/>
             <p14:sldId id="260"/>
             <p14:sldId id="261"/>
           </p14:sldIdLst>
         </p14:section>
-        <p14:section name="Inversión" id="{2db6aa25-9451-c740-55b5-6025e2e35f84}">
+        <p14:section name="Inversión" id="{1beb1d59-6a3d-f4ed-96db-b01ab02607ac}">
           <p14:sldIdLst>
             <p14:sldId id="262"/>
             <p14:sldId id="263"/>
             <p14:sldId id="264"/>
           </p14:sldIdLst>
         </p14:section>
-        <p14:section name="Opcional" id="{23f6625a-d26f-acc0-e11d-34b6d3c9a8f9}">
+        <p14:section name="Opcional" id="{c5d4af59-6b5a-7601-2e45-61a659cb518e}">
           <p14:sldIdLst>
             <p14:sldId id="265"/>
           </p14:sldIdLst>
         </p14:section>
-        <p14:section name="Próximos pasos" id="{818e677e-8dfc-5c0d-3f69-b8fddd6f5787}">
+        <p14:section name="Próximos pasos" id="{1be53b00-35f2-5762-eeb1-1a3dcef20ea2}">
           <p14:sldIdLst>
             <p14:sldId id="266"/>
           </p14:sldIdLst>
@@ -1681,42 +1681,30 @@
           </a:p>
         </p:txBody>
       </p:sp>
-      <p:sp>
-        <p:nvSpPr>
-          <p:cNvPr id="3" name="Text 0"/>
-          <p:cNvSpPr/>
-          <p:nvPr/>
-        </p:nvSpPr>
-        <p:spPr>
-          <a:xfrm>
-            <a:off x="457200" y="4754880"/>
-            <a:ext cx="4572000" cy="274320"/>
-          </a:xfrm>
-          <a:prstGeom prst="rect">
-            <a:avLst/>
-          </a:prstGeom>
-          <a:noFill/>
-          <a:ln/>
-        </p:spPr>
-        <p:txBody>
-          <a:bodyPr wrap="square" lIns="0" tIns="0" rIns="0" bIns="0" rtlCol="0" anchor="ctr"/>
-          <a:lstStyle/>
-          <a:p>
-            <a:pPr indent="0" marL="0">
-              <a:buNone/>
-            </a:pPr>
-            <a:r>
-              <a:rPr lang="en-US" sz="1000" dirty="0">
-                <a:solidFill>
-                  <a:schemeClr val="accent3"/>
-                </a:solidFill>
-              </a:rPr>
-              <a:t>Jurix Global · Plan Ruta Segura</a:t>
-            </a:r>
-            <a:endParaRPr lang="en-US" sz="1000" dirty="0"/>
-          </a:p>
-        </p:txBody>
-      </p:sp>
+      <p:pic>
+        <p:nvPicPr>
+          <p:cNvPr id="3" name="Image 0" descr="Jurix Global Abogados">    </p:cNvPr>
+          <p:cNvPicPr>
+            <a:picLocks noChangeAspect="1"/>
+          </p:cNvPicPr>
+          <p:nvPr/>
+        </p:nvPicPr>
+        <p:blipFill>
+          <a:blip r:embed="rId1"/>
+          <a:stretch>
+            <a:fillRect/>
+          </a:stretch>
+        </p:blipFill>
+        <p:spPr>
+          <a:xfrm>
+            <a:off x="457200" y="4645152"/>
+            <a:ext cx="1051560" cy="345190"/>
+          </a:xfrm>
+          <a:prstGeom prst="rect">
+            <a:avLst/>
+          </a:prstGeom>
+        </p:spPr>
+      </p:pic>
       <p:sp>
         <p:nvSpPr>
           <p:cNvPr id="25" name="Slide Number Placeholder 0"/>
@@ -1833,16 +1821,40 @@
           </a:p>
         </p:txBody>
       </p:sp>
-      <p:sp>
-        <p:nvSpPr>
-          <p:cNvPr id="3" name="Text 0"/>
+      <p:pic>
+        <p:nvPicPr>
+          <p:cNvPr id="3" name="Image 0" descr="Jurix Global Abogados">    </p:cNvPr>
+          <p:cNvPicPr>
+            <a:picLocks noChangeAspect="1"/>
+          </p:cNvPicPr>
+          <p:nvPr/>
+        </p:nvPicPr>
+        <p:blipFill>
+          <a:blip r:embed="rId1"/>
+          <a:stretch>
+            <a:fillRect/>
+          </a:stretch>
+        </p:blipFill>
+        <p:spPr>
+          <a:xfrm>
+            <a:off x="457200" y="4407408"/>
+            <a:ext cx="1463040" cy="480264"/>
+          </a:xfrm>
+          <a:prstGeom prst="rect">
+            <a:avLst/>
+          </a:prstGeom>
+        </p:spPr>
+      </p:pic>
+      <p:sp>
+        <p:nvSpPr>
+          <p:cNvPr id="4" name="Text 0"/>
           <p:cNvSpPr/>
           <p:nvPr/>
         </p:nvSpPr>
         <p:spPr>
           <a:xfrm>
-            <a:off x="457200" y="4709160"/>
-            <a:ext cx="5486400" cy="274320"/>
+            <a:off x="5943600" y="4572000"/>
+            <a:ext cx="2743200" cy="274320"/>
           </a:xfrm>
           <a:prstGeom prst="rect">
             <a:avLst/>
@@ -1854,7 +1866,7 @@
           <a:bodyPr wrap="square" lIns="0" tIns="0" rIns="0" bIns="0" rtlCol="0" anchor="ctr"/>
           <a:lstStyle/>
           <a:p>
-            <a:pPr indent="0" marL="0">
+            <a:pPr algn="r" indent="0" marL="0">
               <a:buNone/>
             </a:pPr>
             <a:r>
@@ -1863,7 +1875,7 @@
                   <a:schemeClr val="accent6"/>
                 </a:solidFill>
               </a:rPr>
-              <a:t>Jurix Global · Guayaquil, Ecuador</a:t>
+              <a:t>Guayaquil, Ecuador</a:t>
             </a:r>
             <a:endParaRPr lang="en-US" sz="1100" dirty="0"/>
           </a:p>
@@ -2219,42 +2231,30 @@
           <a:chExt cx="0" cy="0"/>
         </a:xfrm>
       </p:grpSpPr>
-      <p:sp>
-        <p:nvSpPr>
-          <p:cNvPr id="2" name="Antetítulo"/>
-          <p:cNvSpPr txBox="1"/>
-          <p:nvPr/>
-        </p:nvSpPr>
-        <p:spPr>
-          <a:xfrm>
-            <a:off x="548640" y="960120"/>
-            <a:ext cx="5394960" cy="320040"/>
-          </a:xfrm>
-          <a:prstGeom prst="rect">
-            <a:avLst/>
-          </a:prstGeom>
-          <a:noFill/>
-          <a:ln/>
-        </p:spPr>
-        <p:txBody>
-          <a:bodyPr wrap="square" lIns="0" tIns="0" rIns="0" bIns="0" rtlCol="0" anchor="t"/>
-          <a:lstStyle/>
-          <a:p>
-            <a:pPr indent="0" marL="0">
-              <a:buNone/>
-            </a:pPr>
-            <a:r>
-              <a:rPr lang="en-US" sz="1400" b="1" spc="200" kern="0" dirty="0">
-                <a:solidFill>
-                  <a:schemeClr val="accent1"/>
-                </a:solidFill>
-              </a:rPr>
-              <a:t>JURIX GLOBAL · ABOGADOS EN GUAYAQUIL</a:t>
-            </a:r>
-            <a:endParaRPr lang="en-US" sz="1400" dirty="0"/>
-          </a:p>
-        </p:txBody>
-      </p:sp>
+      <p:pic>
+        <p:nvPicPr>
+          <p:cNvPr id="2" name="Logo Jurix Global" descr="Jurix Global Abogados">    </p:cNvPr>
+          <p:cNvPicPr>
+            <a:picLocks noChangeAspect="1"/>
+          </p:cNvPicPr>
+          <p:nvPr/>
+        </p:nvPicPr>
+        <p:blipFill>
+          <a:blip r:embed="rId1"/>
+          <a:stretch>
+            <a:fillRect/>
+          </a:stretch>
+        </p:blipFill>
+        <p:spPr>
+          <a:xfrm>
+            <a:off x="548640" y="411480"/>
+            <a:ext cx="2377440" cy="780429"/>
+          </a:xfrm>
+          <a:prstGeom prst="rect">
+            <a:avLst/>
+          </a:prstGeom>
+        </p:spPr>
+      </p:pic>
       <p:sp>
         <p:nvSpPr>
           <p:cNvPr id="3" name="Text 0"/>
@@ -2365,7 +2365,7 @@
           <p:nvPr/>
         </p:nvPicPr>
         <p:blipFill>
-          <a:blip r:embed="rId1"/>
+          <a:blip r:embed="rId2"/>
           <a:stretch>
             <a:fillRect/>
           </a:stretch>
@@ -3244,7 +3244,7 @@
         <p:spPr>
           <a:xfrm>
             <a:off x="457200" y="1417320"/>
-            <a:ext cx="2606040" cy="2834640"/>
+            <a:ext cx="2606040" cy="2697480"/>
           </a:xfrm>
           <a:prstGeom prst="roundRect">
             <a:avLst>
@@ -3252,11 +3252,11 @@
             </a:avLst>
           </a:prstGeom>
           <a:solidFill>
-            <a:srgbClr val="1F2F52"/>
+            <a:srgbClr val="16304F"/>
           </a:solidFill>
           <a:ln w="12700">
             <a:solidFill>
-              <a:srgbClr val="1F2F52"/>
+              <a:srgbClr val="16304F"/>
             </a:solidFill>
             <a:prstDash val="solid"/>
           </a:ln>
@@ -3392,7 +3392,7 @@
         <p:spPr>
           <a:xfrm>
             <a:off x="3246120" y="1417320"/>
-            <a:ext cx="2606040" cy="2834640"/>
+            <a:ext cx="2606040" cy="2697480"/>
           </a:xfrm>
           <a:prstGeom prst="roundRect">
             <a:avLst>
@@ -3400,11 +3400,11 @@
             </a:avLst>
           </a:prstGeom>
           <a:solidFill>
-            <a:srgbClr val="1F2F52"/>
+            <a:srgbClr val="16304F"/>
           </a:solidFill>
           <a:ln w="12700">
             <a:solidFill>
-              <a:srgbClr val="1F2F52"/>
+              <a:srgbClr val="16304F"/>
             </a:solidFill>
             <a:prstDash val="solid"/>
           </a:ln>
@@ -3540,7 +3540,7 @@
         <p:spPr>
           <a:xfrm>
             <a:off x="6035040" y="1417320"/>
-            <a:ext cx="2606040" cy="2834640"/>
+            <a:ext cx="2606040" cy="2697480"/>
           </a:xfrm>
           <a:prstGeom prst="roundRect">
             <a:avLst>
@@ -3548,11 +3548,11 @@
             </a:avLst>
           </a:prstGeom>
           <a:solidFill>
-            <a:srgbClr val="1F2F52"/>
+            <a:srgbClr val="16304F"/>
           </a:solidFill>
           <a:ln w="12700">
             <a:solidFill>
-              <a:srgbClr val="1F2F52"/>
+              <a:srgbClr val="16304F"/>
             </a:solidFill>
             <a:prstDash val="solid"/>
           </a:ln>
@@ -3796,7 +3796,7 @@
             <a:r>
               <a:rPr lang="en-US" sz="3400" b="1" dirty="0">
                 <a:solidFill>
-                  <a:schemeClr val="accent1"/>
+                  <a:schemeClr val="accent2"/>
                 </a:solidFill>
                 <a:latin typeface="Cambria" pitchFamily="34" charset="0"/>
                 <a:ea typeface="Cambria" pitchFamily="34" charset="-122"/>
@@ -3898,7 +3898,7 @@
             <a:r>
               <a:rPr lang="en-US" sz="3400" b="1" dirty="0">
                 <a:solidFill>
-                  <a:schemeClr val="accent1"/>
+                  <a:schemeClr val="accent2"/>
                 </a:solidFill>
                 <a:latin typeface="Cambria" pitchFamily="34" charset="0"/>
                 <a:ea typeface="Cambria" pitchFamily="34" charset="-122"/>
@@ -4000,7 +4000,7 @@
             <a:r>
               <a:rPr lang="en-US" sz="3400" b="1" dirty="0">
                 <a:solidFill>
-                  <a:schemeClr val="accent1"/>
+                  <a:schemeClr val="accent2"/>
                 </a:solidFill>
                 <a:latin typeface="Cambria" pitchFamily="34" charset="0"/>
                 <a:ea typeface="Cambria" pitchFamily="34" charset="-122"/>
@@ -6939,7 +6939,7 @@
             <a:r>
               <a:rPr lang="en-US" sz="3400" b="1" dirty="0">
                 <a:solidFill>
-                  <a:schemeClr val="accent1"/>
+                  <a:schemeClr val="accent2"/>
                 </a:solidFill>
                 <a:latin typeface="Cambria" pitchFamily="34" charset="0"/>
                 <a:ea typeface="Cambria" pitchFamily="34" charset="-122"/>
@@ -7215,7 +7215,7 @@
             <a:r>
               <a:rPr lang="en-US" sz="3400" b="1" dirty="0">
                 <a:solidFill>
-                  <a:schemeClr val="accent1"/>
+                  <a:schemeClr val="accent2"/>
                 </a:solidFill>
                 <a:latin typeface="Cambria" pitchFamily="34" charset="0"/>
                 <a:ea typeface="Cambria" pitchFamily="34" charset="-122"/>
@@ -7573,7 +7573,7 @@
                       <a:tailEnd type="none" w="med" len="med"/>
                     </a:lnB>
                     <a:solidFill>
-                      <a:srgbClr val="14213D"/>
+                      <a:srgbClr val="0A1F3A"/>
                     </a:solidFill>
                   </a:tcPr>
                 </a:tc>
@@ -7641,7 +7641,7 @@
                       <a:tailEnd type="none" w="med" len="med"/>
                     </a:lnB>
                     <a:solidFill>
-                      <a:srgbClr val="14213D"/>
+                      <a:srgbClr val="0A1F3A"/>
                     </a:solidFill>
                   </a:tcPr>
                 </a:tc>
@@ -7709,7 +7709,7 @@
                       <a:tailEnd type="none" w="med" len="med"/>
                     </a:lnB>
                     <a:solidFill>
-                      <a:srgbClr val="14213D"/>
+                      <a:srgbClr val="0A1F3A"/>
                     </a:solidFill>
                   </a:tcPr>
                 </a:tc>
@@ -7856,7 +7856,7 @@
                       <a:r>
                         <a:rPr lang="en-US" sz="1400" b="1" dirty="0">
                           <a:solidFill>
-                            <a:srgbClr val="14213D"/>
+                            <a:srgbClr val="0A1F3A"/>
                           </a:solidFill>
                           <a:latin typeface="Calibri" pitchFamily="34" charset="0"/>
                           <a:ea typeface="Calibri" pitchFamily="34" charset="-122"/>
@@ -7909,7 +7909,7 @@
                       <a:tailEnd type="none" w="med" len="med"/>
                     </a:lnB>
                     <a:solidFill>
-                      <a:srgbClr val="FEF0D4"/>
+                      <a:srgbClr val="F3ECDF"/>
                     </a:solidFill>
                   </a:tcPr>
                 </a:tc>
@@ -8056,7 +8056,7 @@
                       <a:r>
                         <a:rPr lang="en-US" sz="1400" b="1" dirty="0">
                           <a:solidFill>
-                            <a:srgbClr val="14213D"/>
+                            <a:srgbClr val="0A1F3A"/>
                           </a:solidFill>
                           <a:latin typeface="Calibri" pitchFamily="34" charset="0"/>
                           <a:ea typeface="Calibri" pitchFamily="34" charset="-122"/>
@@ -8109,7 +8109,7 @@
                       <a:tailEnd type="none" w="med" len="med"/>
                     </a:lnB>
                     <a:solidFill>
-                      <a:srgbClr val="FEF0D4"/>
+                      <a:srgbClr val="F3ECDF"/>
                     </a:solidFill>
                   </a:tcPr>
                 </a:tc>
@@ -8256,7 +8256,7 @@
                       <a:r>
                         <a:rPr lang="en-US" sz="1400" b="1" dirty="0">
                           <a:solidFill>
-                            <a:srgbClr val="14213D"/>
+                            <a:srgbClr val="0A1F3A"/>
                           </a:solidFill>
                           <a:latin typeface="Calibri" pitchFamily="34" charset="0"/>
                           <a:ea typeface="Calibri" pitchFamily="34" charset="-122"/>
@@ -8309,7 +8309,7 @@
                       <a:tailEnd type="none" w="med" len="med"/>
                     </a:lnB>
                     <a:solidFill>
-                      <a:srgbClr val="FEF0D4"/>
+                      <a:srgbClr val="F3ECDF"/>
                     </a:solidFill>
                   </a:tcPr>
                 </a:tc>
@@ -8456,7 +8456,7 @@
                       <a:r>
                         <a:rPr lang="en-US" sz="1400" b="1" dirty="0">
                           <a:solidFill>
-                            <a:srgbClr val="14213D"/>
+                            <a:srgbClr val="0A1F3A"/>
                           </a:solidFill>
                           <a:latin typeface="Calibri" pitchFamily="34" charset="0"/>
                           <a:ea typeface="Calibri" pitchFamily="34" charset="-122"/>
@@ -8509,7 +8509,7 @@
                       <a:tailEnd type="none" w="med" len="med"/>
                     </a:lnB>
                     <a:solidFill>
-                      <a:srgbClr val="FEF0D4"/>
+                      <a:srgbClr val="F3ECDF"/>
                     </a:solidFill>
                   </a:tcPr>
                 </a:tc>
@@ -9634,16 +9634,16 @@
         <a:srgbClr val="FFFFFF"/>
       </a:lt1>
       <a:dk2>
-        <a:srgbClr val="14213D"/>
+        <a:srgbClr val="0A1F3A"/>
       </a:dk2>
       <a:lt2>
         <a:srgbClr val="F2F4F7"/>
       </a:lt2>
       <a:accent1>
-        <a:srgbClr val="FCA311"/>
+        <a:srgbClr val="B7955A"/>
       </a:accent1>
       <a:accent2>
-        <a:srgbClr val="14213D"/>
+        <a:srgbClr val="8C6D36"/>
       </a:accent2>
       <a:accent3>
         <a:srgbClr val="5C677D"/>
@@ -9655,7 +9655,7 @@
         <a:srgbClr val="2A9D8F"/>
       </a:accent5>
       <a:accent6>
-        <a:srgbClr val="CBD5E1"/>
+        <a:srgbClr val="C9D1DC"/>
       </a:accent6>
       <a:hlink>
         <a:srgbClr val="1F6FEB"/>

</xml_diff>

<commit_message>
Agregar contacto de WhatsApp y teléfono al cierre de las presentaciones
Co-Authored-By: Claude Opus 5.5 <noreply@anthropic.com>
Claude-Session: https://claude.ai/code/session_01QAe3YyGWhdhctfhZWNy5HL
</commit_message>
<xml_diff>
--- a/jurix-global/presentacion-plan-ruta-segura-version-b.pptx
+++ b/jurix-global/presentacion-plan-ruta-segura-version-b.pptx
@@ -117,37 +117,37 @@
   <p:extLst>
     <p:ext uri="{521415D9-36F7-43E2-AB2F-B90AF26B5E84}">
       <p14:sectionLst xmlns:p14="http://schemas.microsoft.com/office/powerpoint/2010/main">
-        <p14:section name="Apertura" id="{709f479f-c552-e7e9-62c6-4a6c8d7fe35a}">
+        <p14:section name="Apertura" id="{343246de-5f11-4423-c286-2629257ed007}">
           <p14:sldIdLst>
             <p14:sldId id="256"/>
           </p14:sldIdLst>
         </p14:section>
-        <p14:section name="El problema" id="{4704ffa8-205a-090a-b3c4-398687537b2b}">
+        <p14:section name="El problema" id="{20d762ac-3ed3-fc5f-d429-ae2810af28de}">
           <p14:sldIdLst>
             <p14:sldId id="257"/>
             <p14:sldId id="258"/>
           </p14:sldIdLst>
         </p14:section>
-        <p14:section name="La solución" id="{35c0c289-ef6d-7bba-ad27-f678abefccd6}">
+        <p14:section name="La solución" id="{0e682944-5b8e-d914-e301-74c4fb3c94c4}">
           <p14:sldIdLst>
             <p14:sldId id="259"/>
             <p14:sldId id="260"/>
             <p14:sldId id="261"/>
           </p14:sldIdLst>
         </p14:section>
-        <p14:section name="Inversión" id="{1beb1d59-6a3d-f4ed-96db-b01ab02607ac}">
+        <p14:section name="Inversión" id="{523e1381-5653-9821-9adf-4cbb57dc7354}">
           <p14:sldIdLst>
             <p14:sldId id="262"/>
             <p14:sldId id="263"/>
             <p14:sldId id="264"/>
           </p14:sldIdLst>
         </p14:section>
-        <p14:section name="Opcional" id="{c5d4af59-6b5a-7601-2e45-61a659cb518e}">
+        <p14:section name="Opcional" id="{d05bf1bc-5dee-dd89-ef81-eb2562855b58}">
           <p14:sldIdLst>
             <p14:sldId id="265"/>
           </p14:sldIdLst>
         </p14:section>
-        <p14:section name="Próximos pasos" id="{1be53b00-35f2-5762-eeb1-1a3dcef20ea2}">
+        <p14:section name="Próximos pasos" id="{906fdde1-8db8-f7b1-ada7-fc4bc39cc608}">
           <p14:sldIdLst>
             <p14:sldId id="266"/>
           </p14:sldIdLst>
@@ -1853,8 +1853,8 @@
         </p:nvSpPr>
         <p:spPr>
           <a:xfrm>
-            <a:off x="5943600" y="4572000"/>
-            <a:ext cx="2743200" cy="274320"/>
+            <a:off x="4572000" y="4434840"/>
+            <a:ext cx="4114800" cy="320040"/>
           </a:xfrm>
           <a:prstGeom prst="rect">
             <a:avLst/>
@@ -1870,14 +1870,50 @@
               <a:buNone/>
             </a:pPr>
             <a:r>
-              <a:rPr lang="en-US" sz="1100" dirty="0">
+              <a:rPr lang="en-US" sz="1600" b="1" dirty="0">
+                <a:solidFill>
+                  <a:schemeClr val="accent1"/>
+                </a:solidFill>
+              </a:rPr>
+              <a:t>WhatsApp y teléfono: 098 780 4294</a:t>
+            </a:r>
+            <a:endParaRPr lang="en-US" sz="1600" dirty="0"/>
+          </a:p>
+        </p:txBody>
+      </p:sp>
+      <p:sp>
+        <p:nvSpPr>
+          <p:cNvPr id="5" name="Text 1"/>
+          <p:cNvSpPr/>
+          <p:nvPr/>
+        </p:nvSpPr>
+        <p:spPr>
+          <a:xfrm>
+            <a:off x="4572000" y="4754880"/>
+            <a:ext cx="4114800" cy="274320"/>
+          </a:xfrm>
+          <a:prstGeom prst="rect">
+            <a:avLst/>
+          </a:prstGeom>
+          <a:noFill/>
+          <a:ln/>
+        </p:spPr>
+        <p:txBody>
+          <a:bodyPr wrap="square" lIns="0" tIns="0" rIns="0" bIns="0" rtlCol="0" anchor="ctr"/>
+          <a:lstStyle/>
+          <a:p>
+            <a:pPr algn="r" indent="0" marL="0">
+              <a:buNone/>
+            </a:pPr>
+            <a:r>
+              <a:rPr lang="en-US" sz="1200" dirty="0">
                 <a:solidFill>
                   <a:schemeClr val="accent6"/>
                 </a:solidFill>
               </a:rPr>
               <a:t>Guayaquil, Ecuador</a:t>
             </a:r>
-            <a:endParaRPr lang="en-US" sz="1100" dirty="0"/>
+            <a:endParaRPr lang="en-US" sz="1200" dirty="0"/>
           </a:p>
         </p:txBody>
       </p:sp>

</xml_diff>

<commit_message>
Adoptar el nuevo logo de Jurix Global en todos los materiales
Reemplaza el logo y la paleta azul marino y dorado por el nuevo logo
azul y gris en presentaciones, hoja del Plan Familia y guiones de video;
registra la identidad visual en la ficha del estudio y en el agente, y
archiva el logo anterior.

Co-Authored-By: Claude Opus 5.5 <noreply@anthropic.com>
Claude-Session: https://claude.ai/code/session_01QAe3YyGWhdhctfhZWNy5HL
</commit_message>
<xml_diff>
--- a/jurix-global/presentacion-plan-ruta-segura-version-b.pptx
+++ b/jurix-global/presentacion-plan-ruta-segura-version-b.pptx
@@ -117,37 +117,37 @@
   <p:extLst>
     <p:ext uri="{521415D9-36F7-43E2-AB2F-B90AF26B5E84}">
       <p14:sectionLst xmlns:p14="http://schemas.microsoft.com/office/powerpoint/2010/main">
-        <p14:section name="Apertura" id="{343246de-5f11-4423-c286-2629257ed007}">
+        <p14:section name="Apertura" id="{bee6dc2e-e633-7244-d8d1-bfddc6835f0f}">
           <p14:sldIdLst>
             <p14:sldId id="256"/>
           </p14:sldIdLst>
         </p14:section>
-        <p14:section name="El problema" id="{20d762ac-3ed3-fc5f-d429-ae2810af28de}">
+        <p14:section name="El problema" id="{fe1b71aa-31aa-6de5-a6b1-cb17ec5c1190}">
           <p14:sldIdLst>
             <p14:sldId id="257"/>
             <p14:sldId id="258"/>
           </p14:sldIdLst>
         </p14:section>
-        <p14:section name="La solución" id="{0e682944-5b8e-d914-e301-74c4fb3c94c4}">
+        <p14:section name="La solución" id="{cf62f62f-1063-d547-3447-bc7a484d847f}">
           <p14:sldIdLst>
             <p14:sldId id="259"/>
             <p14:sldId id="260"/>
             <p14:sldId id="261"/>
           </p14:sldIdLst>
         </p14:section>
-        <p14:section name="Inversión" id="{523e1381-5653-9821-9adf-4cbb57dc7354}">
+        <p14:section name="Inversión" id="{8f6e0d91-821c-d1bd-9cbe-c94d163b31c1}">
           <p14:sldIdLst>
             <p14:sldId id="262"/>
             <p14:sldId id="263"/>
             <p14:sldId id="264"/>
           </p14:sldIdLst>
         </p14:section>
-        <p14:section name="Opcional" id="{d05bf1bc-5dee-dd89-ef81-eb2562855b58}">
+        <p14:section name="Opcional" id="{3e145b61-9ff0-71da-0cd2-4693d5a128e1}">
           <p14:sldIdLst>
             <p14:sldId id="265"/>
           </p14:sldIdLst>
         </p14:section>
-        <p14:section name="Próximos pasos" id="{906fdde1-8db8-f7b1-ada7-fc4bc39cc608}">
+        <p14:section name="Próximos pasos" id="{8412e726-ea62-b16b-8a3d-7404a8cb1c59}">
           <p14:sldIdLst>
             <p14:sldId id="266"/>
           </p14:sldIdLst>
@@ -1683,7 +1683,7 @@
       </p:sp>
       <p:pic>
         <p:nvPicPr>
-          <p:cNvPr id="3" name="Image 0" descr="Jurix Global Abogados">    </p:cNvPr>
+          <p:cNvPr id="3" name="Image 0" descr="Jurix Global, asesoría legal y financiera">    </p:cNvPr>
           <p:cNvPicPr>
             <a:picLocks noChangeAspect="1"/>
           </p:cNvPicPr>
@@ -1697,8 +1697,8 @@
         </p:blipFill>
         <p:spPr>
           <a:xfrm>
-            <a:off x="457200" y="4645152"/>
-            <a:ext cx="1051560" cy="345190"/>
+            <a:off x="457200" y="4636008"/>
+            <a:ext cx="868680" cy="392598"/>
           </a:xfrm>
           <a:prstGeom prst="rect">
             <a:avLst/>
@@ -1823,7 +1823,7 @@
       </p:sp>
       <p:pic>
         <p:nvPicPr>
-          <p:cNvPr id="3" name="Image 0" descr="Jurix Global Abogados">    </p:cNvPr>
+          <p:cNvPr id="3" name="Image 0" descr="Jurix Global, asesoría legal y financiera">    </p:cNvPr>
           <p:cNvPicPr>
             <a:picLocks noChangeAspect="1"/>
           </p:cNvPicPr>
@@ -1837,8 +1837,8 @@
         </p:blipFill>
         <p:spPr>
           <a:xfrm>
-            <a:off x="457200" y="4407408"/>
-            <a:ext cx="1463040" cy="480264"/>
+            <a:off x="457200" y="4343400"/>
+            <a:ext cx="1371600" cy="619892"/>
           </a:xfrm>
           <a:prstGeom prst="rect">
             <a:avLst/>
@@ -1872,7 +1872,7 @@
             <a:r>
               <a:rPr lang="en-US" sz="1600" b="1" dirty="0">
                 <a:solidFill>
-                  <a:schemeClr val="accent1"/>
+                  <a:srgbClr val="8FB4F0"/>
                 </a:solidFill>
               </a:rPr>
               <a:t>WhatsApp y teléfono: 098 780 4294</a:t>
@@ -2269,7 +2269,7 @@
       </p:grpSpPr>
       <p:pic>
         <p:nvPicPr>
-          <p:cNvPr id="2" name="Logo Jurix Global" descr="Jurix Global Abogados">    </p:cNvPr>
+          <p:cNvPr id="2" name="Logo Jurix Global" descr="Jurix Global, asesoría legal y financiera">    </p:cNvPr>
           <p:cNvPicPr>
             <a:picLocks noChangeAspect="1"/>
           </p:cNvPicPr>
@@ -2283,8 +2283,8 @@
         </p:blipFill>
         <p:spPr>
           <a:xfrm>
-            <a:off x="548640" y="411480"/>
-            <a:ext cx="2377440" cy="780429"/>
+            <a:off x="548640" y="320040"/>
+            <a:ext cx="2011680" cy="909175"/>
           </a:xfrm>
           <a:prstGeom prst="rect">
             <a:avLst/>
@@ -2382,11 +2382,11 @@
             <a:avLst/>
           </a:prstGeom>
           <a:solidFill>
-            <a:schemeClr val="accent1"/>
+            <a:schemeClr val="bg1"/>
           </a:solidFill>
           <a:ln w="12700">
             <a:solidFill>
-              <a:schemeClr val="accent1"/>
+              <a:schemeClr val="bg1"/>
             </a:solidFill>
             <a:prstDash val="solid"/>
           </a:ln>
@@ -3079,7 +3079,7 @@
             <a:r>
               <a:rPr lang="en-US" sz="4000" b="1" dirty="0">
                 <a:solidFill>
-                  <a:schemeClr val="accent1"/>
+                  <a:srgbClr val="8FB4F0"/>
                 </a:solidFill>
                 <a:latin typeface="Cambria" pitchFamily="34" charset="0"/>
                 <a:ea typeface="Cambria" pitchFamily="34" charset="-122"/>
@@ -3288,11 +3288,11 @@
             </a:avLst>
           </a:prstGeom>
           <a:solidFill>
-            <a:srgbClr val="16304F"/>
+            <a:srgbClr val="153B73"/>
           </a:solidFill>
           <a:ln w="12700">
             <a:solidFill>
-              <a:srgbClr val="16304F"/>
+              <a:srgbClr val="153B73"/>
             </a:solidFill>
             <a:prstDash val="solid"/>
           </a:ln>
@@ -3313,11 +3313,11 @@
             <a:avLst/>
           </a:prstGeom>
           <a:solidFill>
-            <a:schemeClr val="accent1"/>
+            <a:schemeClr val="bg1"/>
           </a:solidFill>
           <a:ln w="12700">
             <a:solidFill>
-              <a:schemeClr val="accent1"/>
+              <a:schemeClr val="bg1"/>
             </a:solidFill>
             <a:prstDash val="solid"/>
           </a:ln>
@@ -3374,7 +3374,7 @@
             <a:r>
               <a:rPr lang="en-US" sz="1600" b="1" dirty="0">
                 <a:solidFill>
-                  <a:schemeClr val="accent1"/>
+                  <a:srgbClr val="8FB4F0"/>
                 </a:solidFill>
               </a:rPr>
               <a:t>1. Diagnóstico gratuito</a:t>
@@ -3436,11 +3436,11 @@
             </a:avLst>
           </a:prstGeom>
           <a:solidFill>
-            <a:srgbClr val="16304F"/>
+            <a:srgbClr val="153B73"/>
           </a:solidFill>
           <a:ln w="12700">
             <a:solidFill>
-              <a:srgbClr val="16304F"/>
+              <a:srgbClr val="153B73"/>
             </a:solidFill>
             <a:prstDash val="solid"/>
           </a:ln>
@@ -3461,11 +3461,11 @@
             <a:avLst/>
           </a:prstGeom>
           <a:solidFill>
-            <a:schemeClr val="accent1"/>
+            <a:schemeClr val="bg1"/>
           </a:solidFill>
           <a:ln w="12700">
             <a:solidFill>
-              <a:schemeClr val="accent1"/>
+              <a:schemeClr val="bg1"/>
             </a:solidFill>
             <a:prstDash val="solid"/>
           </a:ln>
@@ -3522,7 +3522,7 @@
             <a:r>
               <a:rPr lang="en-US" sz="1600" b="1" dirty="0">
                 <a:solidFill>
-                  <a:schemeClr val="accent1"/>
+                  <a:srgbClr val="8FB4F0"/>
                 </a:solidFill>
               </a:rPr>
               <a:t>2. Presentación</a:t>
@@ -3584,11 +3584,11 @@
             </a:avLst>
           </a:prstGeom>
           <a:solidFill>
-            <a:srgbClr val="16304F"/>
+            <a:srgbClr val="153B73"/>
           </a:solidFill>
           <a:ln w="12700">
             <a:solidFill>
-              <a:srgbClr val="16304F"/>
+              <a:srgbClr val="153B73"/>
             </a:solidFill>
             <a:prstDash val="solid"/>
           </a:ln>
@@ -3609,11 +3609,11 @@
             <a:avLst/>
           </a:prstGeom>
           <a:solidFill>
-            <a:schemeClr val="accent1"/>
+            <a:schemeClr val="bg1"/>
           </a:solidFill>
           <a:ln w="12700">
             <a:solidFill>
-              <a:schemeClr val="accent1"/>
+              <a:schemeClr val="bg1"/>
             </a:solidFill>
             <a:prstDash val="solid"/>
           </a:ln>
@@ -3670,7 +3670,7 @@
             <a:r>
               <a:rPr lang="en-US" sz="1600" b="1" dirty="0">
                 <a:solidFill>
-                  <a:schemeClr val="accent1"/>
+                  <a:srgbClr val="8FB4F0"/>
                 </a:solidFill>
               </a:rPr>
               <a:t>3. Activación en 30 días</a:t>
@@ -4645,7 +4645,7 @@
             <a:r>
               <a:rPr lang="en-US" sz="2200" b="1" dirty="0">
                 <a:solidFill>
-                  <a:schemeClr val="accent1"/>
+                  <a:srgbClr val="8FB4F0"/>
                 </a:solidFill>
                 <a:latin typeface="Cambria" pitchFamily="34" charset="0"/>
                 <a:ea typeface="Cambria" pitchFamily="34" charset="-122"/>
@@ -7113,7 +7113,7 @@
             <a:r>
               <a:rPr lang="en-US" sz="3400" b="1" dirty="0">
                 <a:solidFill>
-                  <a:schemeClr val="accent1"/>
+                  <a:srgbClr val="8FB4F0"/>
                 </a:solidFill>
                 <a:latin typeface="Cambria" pitchFamily="34" charset="0"/>
                 <a:ea typeface="Cambria" pitchFamily="34" charset="-122"/>
@@ -7609,7 +7609,7 @@
                       <a:tailEnd type="none" w="med" len="med"/>
                     </a:lnB>
                     <a:solidFill>
-                      <a:srgbClr val="0A1F3A"/>
+                      <a:srgbClr val="0B2A5B"/>
                     </a:solidFill>
                   </a:tcPr>
                 </a:tc>
@@ -7677,7 +7677,7 @@
                       <a:tailEnd type="none" w="med" len="med"/>
                     </a:lnB>
                     <a:solidFill>
-                      <a:srgbClr val="0A1F3A"/>
+                      <a:srgbClr val="0B2A5B"/>
                     </a:solidFill>
                   </a:tcPr>
                 </a:tc>
@@ -7745,7 +7745,7 @@
                       <a:tailEnd type="none" w="med" len="med"/>
                     </a:lnB>
                     <a:solidFill>
-                      <a:srgbClr val="0A1F3A"/>
+                      <a:srgbClr val="0B2A5B"/>
                     </a:solidFill>
                   </a:tcPr>
                 </a:tc>
@@ -7892,7 +7892,7 @@
                       <a:r>
                         <a:rPr lang="en-US" sz="1400" b="1" dirty="0">
                           <a:solidFill>
-                            <a:srgbClr val="0A1F3A"/>
+                            <a:srgbClr val="014BAD"/>
                           </a:solidFill>
                           <a:latin typeface="Calibri" pitchFamily="34" charset="0"/>
                           <a:ea typeface="Calibri" pitchFamily="34" charset="-122"/>
@@ -7945,7 +7945,7 @@
                       <a:tailEnd type="none" w="med" len="med"/>
                     </a:lnB>
                     <a:solidFill>
-                      <a:srgbClr val="F3ECDF"/>
+                      <a:srgbClr val="E6EEFA"/>
                     </a:solidFill>
                   </a:tcPr>
                 </a:tc>
@@ -8092,7 +8092,7 @@
                       <a:r>
                         <a:rPr lang="en-US" sz="1400" b="1" dirty="0">
                           <a:solidFill>
-                            <a:srgbClr val="0A1F3A"/>
+                            <a:srgbClr val="014BAD"/>
                           </a:solidFill>
                           <a:latin typeface="Calibri" pitchFamily="34" charset="0"/>
                           <a:ea typeface="Calibri" pitchFamily="34" charset="-122"/>
@@ -8145,7 +8145,7 @@
                       <a:tailEnd type="none" w="med" len="med"/>
                     </a:lnB>
                     <a:solidFill>
-                      <a:srgbClr val="F3ECDF"/>
+                      <a:srgbClr val="E6EEFA"/>
                     </a:solidFill>
                   </a:tcPr>
                 </a:tc>
@@ -8292,7 +8292,7 @@
                       <a:r>
                         <a:rPr lang="en-US" sz="1400" b="1" dirty="0">
                           <a:solidFill>
-                            <a:srgbClr val="0A1F3A"/>
+                            <a:srgbClr val="014BAD"/>
                           </a:solidFill>
                           <a:latin typeface="Calibri" pitchFamily="34" charset="0"/>
                           <a:ea typeface="Calibri" pitchFamily="34" charset="-122"/>
@@ -8345,7 +8345,7 @@
                       <a:tailEnd type="none" w="med" len="med"/>
                     </a:lnB>
                     <a:solidFill>
-                      <a:srgbClr val="F3ECDF"/>
+                      <a:srgbClr val="E6EEFA"/>
                     </a:solidFill>
                   </a:tcPr>
                 </a:tc>
@@ -8492,7 +8492,7 @@
                       <a:r>
                         <a:rPr lang="en-US" sz="1400" b="1" dirty="0">
                           <a:solidFill>
-                            <a:srgbClr val="0A1F3A"/>
+                            <a:srgbClr val="014BAD"/>
                           </a:solidFill>
                           <a:latin typeface="Calibri" pitchFamily="34" charset="0"/>
                           <a:ea typeface="Calibri" pitchFamily="34" charset="-122"/>
@@ -8545,7 +8545,7 @@
                       <a:tailEnd type="none" w="med" len="med"/>
                     </a:lnB>
                     <a:solidFill>
-                      <a:srgbClr val="F3ECDF"/>
+                      <a:srgbClr val="E6EEFA"/>
                     </a:solidFill>
                   </a:tcPr>
                 </a:tc>
@@ -8608,7 +8608,7 @@
             <a:r>
               <a:rPr lang="en-US" sz="4800" b="1" dirty="0">
                 <a:solidFill>
-                  <a:schemeClr val="accent1"/>
+                  <a:srgbClr val="8FB4F0"/>
                 </a:solidFill>
                 <a:latin typeface="Cambria" pitchFamily="34" charset="0"/>
                 <a:ea typeface="Cambria" pitchFamily="34" charset="-122"/>
@@ -9670,19 +9670,19 @@
         <a:srgbClr val="FFFFFF"/>
       </a:lt1>
       <a:dk2>
-        <a:srgbClr val="0A1F3A"/>
+        <a:srgbClr val="0B2A5B"/>
       </a:dk2>
       <a:lt2>
         <a:srgbClr val="F2F4F7"/>
       </a:lt2>
       <a:accent1>
-        <a:srgbClr val="B7955A"/>
+        <a:srgbClr val="014BAD"/>
       </a:accent1>
       <a:accent2>
-        <a:srgbClr val="8C6D36"/>
+        <a:srgbClr val="014BAD"/>
       </a:accent2>
       <a:accent3>
-        <a:srgbClr val="5C677D"/>
+        <a:srgbClr val="727272"/>
       </a:accent3>
       <a:accent4>
         <a:srgbClr val="C0392B"/>
@@ -9691,7 +9691,7 @@
         <a:srgbClr val="2A9D8F"/>
       </a:accent5>
       <a:accent6>
-        <a:srgbClr val="C9D1DC"/>
+        <a:srgbClr val="C8D3E6"/>
       </a:accent6>
       <a:hlink>
         <a:srgbClr val="1F6FEB"/>

</xml_diff>